<commit_message>
Fix QE truncation: concat-aware token filter, v2 deploy script, wave-1 results
- prepare_data.py: rows must satisfy src+mt <= 508 tokens (CometKiwi encodes
  mt+src as ONE 512-token sequence; the per-side 480 cap let 7.8-10.7% of long
  training rows overflow for the QE arms). Also guard seg_id contiguity in
  windows().
- slurm/deploy_concat_fix.sh: rebuild pools+mixes into wmt_length_data_v2 and
  relaunch arms (ckpts -> retrain-wmt-v2); v1 untouched. eval_correlation.sh
  gains VAL_DATA_DIR.
- report: wave-1 results (per-k, MetaDocEval, block-xSIM), pipeline-audit
  paragraph, matched-core exact numbers.
- deck: repo-relative paths, stale status slide replaced by results + audit
  slides (15 slides).

Co-Authored-By: Claude Fable 5 <noreply@anthropic.com>
</commit_message>
<xml_diff>
--- a/docs/FDTEM_length_training_experiment.pptx
+++ b/docs/FDTEM_length_training_experiment.pptx
@@ -16,6 +16,10 @@
     <p:sldId id="264" r:id="rId15"/>
     <p:sldId id="265" r:id="rId16"/>
     <p:sldId id="266" r:id="rId17"/>
+    <p:sldId id="267" r:id="rId18"/>
+    <p:sldId id="268" r:id="rId19"/>
+    <p:sldId id="269" r:id="rId20"/>
+    <p:sldId id="270" r:id="rId21"/>
   </p:sldIdLst>
   <p:sldSz cx="12191695" cy="6858000" type="screen4x3"/>
   <p:notesSz cx="6858000" cy="9144000"/>
@@ -3794,7 +3798,7 @@
                 </a:solidFill>
                 <a:latin typeface="Calibri"/>
               </a:rPr>
-              <a:t>Status</a:t>
+              <a:t>A silent failure, then a correction</a:t>
             </a:r>
           </a:p>
         </p:txBody>
@@ -3836,7 +3840,7 @@
                 </a:solidFill>
                 <a:latin typeface="Calibri"/>
               </a:rPr>
-              <a:t>Running on the cluster.</a:t>
+              <a:t>The first 36-run sweep did not measure composition.</a:t>
             </a:r>
           </a:p>
         </p:txBody>
@@ -3885,24 +3889,236 @@
           </a:p>
         </p:txBody>
       </p:sp>
-      <p:sp>
-        <p:nvSpPr>
-          <p:cNvPr id="5" name="Rounded Rectangle 4"/>
+      <p:pic>
+        <p:nvPicPr>
+          <p:cNvPr id="5" name="Picture 4" descr="wandb_bell.png"/>
+          <p:cNvPicPr>
+            <a:picLocks noChangeAspect="1"/>
+          </p:cNvPicPr>
+          <p:nvPr/>
+        </p:nvPicPr>
+        <p:blipFill>
+          <a:blip r:embed="rId2"/>
+          <a:stretch>
+            <a:fillRect/>
+          </a:stretch>
+        </p:blipFill>
+        <p:spPr>
+          <a:xfrm>
+            <a:off x="2914525" y="1828800"/>
+            <a:ext cx="6362645" cy="2834640"/>
+          </a:xfrm>
+          <a:prstGeom prst="rect">
+            <a:avLst/>
+          </a:prstGeom>
+        </p:spPr>
+      </p:pic>
+      <p:sp>
+        <p:nvSpPr>
+          <p:cNvPr id="6" name="TextBox 5"/>
+          <p:cNvSpPr txBox="1"/>
+          <p:nvPr/>
+        </p:nvSpPr>
+        <p:spPr>
+          <a:xfrm>
+            <a:off x="640080" y="4983480"/>
+            <a:ext cx="10881360" cy="1371600"/>
+          </a:xfrm>
+          <a:prstGeom prst="rect">
+            <a:avLst/>
+          </a:prstGeom>
+          <a:noFill/>
+        </p:spPr>
+        <p:txBody>
+          <a:bodyPr wrap="square" lIns="0" rIns="0" tIns="0" bIns="0">
+            <a:spAutoFit/>
+          </a:bodyPr>
+          <a:lstStyle/>
+          <a:p>
+            <a:pPr algn="l">
+              <a:lnSpc>
+                <a:spcPct val="115000"/>
+              </a:lnSpc>
+              <a:spcAft>
+                <a:spcPts val="600"/>
+              </a:spcAft>
+            </a:pPr>
+            <a:r>
+              <a:rPr sz="1600" b="0">
+                <a:solidFill>
+                  <a:srgbClr val="0B0B0B"/>
+                </a:solidFill>
+                <a:latin typeface="Calibri"/>
+              </a:rPr>
+              <a:t>COMET reads ONE training file per epoch — every run trained on 205–6,940 rows</a:t>
+            </a:r>
+          </a:p>
+          <a:p>
+            <a:pPr algn="l">
+              <a:lnSpc>
+                <a:spcPct val="115000"/>
+              </a:lnSpc>
+              <a:spcAft>
+                <a:spcPts val="600"/>
+              </a:spcAft>
+            </a:pPr>
+            <a:r>
+              <a:rPr sz="1600" b="0">
+                <a:solidFill>
+                  <a:srgbClr val="0B0B0B"/>
+                </a:solidFill>
+                <a:latin typeface="Calibri"/>
+              </a:rPr>
+              <a:t>instead of its 24,000-row mixture, on a single language pair.  Budgets differed ~34×.</a:t>
+            </a:r>
+          </a:p>
+          <a:p>
+            <a:pPr algn="l">
+              <a:lnSpc>
+                <a:spcPct val="115000"/>
+              </a:lnSpc>
+              <a:spcAft>
+                <a:spcPts val="600"/>
+              </a:spcAft>
+            </a:pPr>
+            <a:r>
+              <a:rPr sz="1600" b="0">
+                <a:solidFill>
+                  <a:srgbClr val="0B0B0B"/>
+                </a:solidFill>
+                <a:latin typeface="Calibri"/>
+              </a:rPr>
+              <a:t>Fixed: one concatenated file per mixture, 6 epochs everywhere, best-checkpoint selection.</a:t>
+            </a:r>
+          </a:p>
+        </p:txBody>
+      </p:sp>
+    </p:spTree>
+  </p:cSld>
+  <p:clrMapOvr>
+    <a:masterClrMapping/>
+  </p:clrMapOvr>
+</p:sld>
+</file>
+
+<file path=ppt/slides/slide12.xml><?xml version="1.0" encoding="utf-8"?>
+<p:sld xmlns:a="http://schemas.openxmlformats.org/drawingml/2006/main" xmlns:p="http://schemas.openxmlformats.org/presentationml/2006/main" xmlns:r="http://schemas.openxmlformats.org/officeDocument/2006/relationships">
+  <p:cSld>
+    <p:bg>
+      <p:bgPr>
+        <a:solidFill>
+          <a:srgbClr val="FFFFFF"/>
+        </a:solidFill>
+        <a:effectLst/>
+      </p:bgPr>
+    </p:bg>
+    <p:spTree>
+      <p:nvGrpSpPr>
+        <p:cNvPr id="1" name=""/>
+        <p:cNvGrpSpPr/>
+        <p:nvPr/>
+      </p:nvGrpSpPr>
+      <p:grpSpPr/>
+      <p:sp>
+        <p:nvSpPr>
+          <p:cNvPr id="2" name="TextBox 1"/>
+          <p:cNvSpPr txBox="1"/>
+          <p:nvPr/>
+        </p:nvSpPr>
+        <p:spPr>
+          <a:xfrm>
+            <a:off x="640080" y="411480"/>
+            <a:ext cx="10972800" cy="822960"/>
+          </a:xfrm>
+          <a:prstGeom prst="rect">
+            <a:avLst/>
+          </a:prstGeom>
+          <a:noFill/>
+        </p:spPr>
+        <p:txBody>
+          <a:bodyPr wrap="square" lIns="0" rIns="0" tIns="0" bIns="0">
+            <a:spAutoFit/>
+          </a:bodyPr>
+          <a:lstStyle/>
+          <a:p>
+            <a:pPr algn="l">
+              <a:lnSpc>
+                <a:spcPct val="115000"/>
+              </a:lnSpc>
+              <a:spcAft>
+                <a:spcPts val="600"/>
+              </a:spcAft>
+            </a:pPr>
+            <a:r>
+              <a:rPr sz="3200" b="1">
+                <a:solidFill>
+                  <a:srgbClr val="0B0B0B"/>
+                </a:solidFill>
+                <a:latin typeface="Calibri"/>
+              </a:rPr>
+              <a:t>First corrected wave — correlation</a:t>
+            </a:r>
+          </a:p>
+        </p:txBody>
+      </p:sp>
+      <p:sp>
+        <p:nvSpPr>
+          <p:cNvPr id="3" name="TextBox 2"/>
+          <p:cNvSpPr txBox="1"/>
+          <p:nvPr/>
+        </p:nvSpPr>
+        <p:spPr>
+          <a:xfrm>
+            <a:off x="640080" y="1115568"/>
+            <a:ext cx="10972800" cy="457200"/>
+          </a:xfrm>
+          <a:prstGeom prst="rect">
+            <a:avLst/>
+          </a:prstGeom>
+          <a:noFill/>
+        </p:spPr>
+        <p:txBody>
+          <a:bodyPr wrap="square" lIns="0" rIns="0" tIns="0" bIns="0">
+            <a:spAutoFit/>
+          </a:bodyPr>
+          <a:lstStyle/>
+          <a:p>
+            <a:pPr algn="l">
+              <a:lnSpc>
+                <a:spcPct val="115000"/>
+              </a:lnSpc>
+              <a:spcAft>
+                <a:spcPts val="600"/>
+              </a:spcAft>
+            </a:pPr>
+            <a:r>
+              <a:rPr sz="1600" b="0">
+                <a:solidFill>
+                  <a:srgbClr val="52514E"/>
+                </a:solidFill>
+                <a:latin typeface="Calibri"/>
+              </a:rPr>
+              <a:t>8 arms: frac000 / frac100 × DA / QE × frozen / trained.  Held-out test sets.</a:t>
+            </a:r>
+          </a:p>
+        </p:txBody>
+      </p:sp>
+      <p:sp>
+        <p:nvSpPr>
+          <p:cNvPr id="4" name="Rectangle 3"/>
           <p:cNvSpPr/>
           <p:nvPr/>
         </p:nvSpPr>
         <p:spPr>
           <a:xfrm>
-            <a:off x="640080" y="2148840"/>
-            <a:ext cx="2528316" cy="1554480"/>
-          </a:xfrm>
-          <a:prstGeom prst="roundRect">
-            <a:avLst>
-              <a:gd name="adj" fmla="val 6000"/>
-            </a:avLst>
+            <a:off x="640080" y="1600200"/>
+            <a:ext cx="10881360" cy="25400"/>
+          </a:xfrm>
+          <a:prstGeom prst="rect">
+            <a:avLst/>
           </a:prstGeom>
           <a:solidFill>
-            <a:srgbClr val="F5F5F3"/>
+            <a:srgbClr val="E3E2DE"/>
           </a:solidFill>
           <a:ln>
             <a:noFill/>
@@ -3924,52 +4140,224 @@
           </a:fontRef>
         </p:style>
         <p:txBody>
-          <a:bodyPr rtlCol="0" anchor="ctr" wrap="square" lIns="109728" rIns="109728"/>
+          <a:bodyPr rtlCol="0" anchor="ctr"/>
           <a:lstStyle/>
           <a:p>
             <a:pPr algn="ctr"/>
-            <a:r>
-              <a:rPr sz="3000" b="1">
-                <a:solidFill>
-                  <a:srgbClr val="2A78D6"/>
-                </a:solidFill>
-                <a:latin typeface="Calibri"/>
-              </a:rPr>
-              <a:t>2</a:t>
-            </a:r>
-          </a:p>
-          <a:p>
-            <a:pPr algn="ctr"/>
-            <a:r>
-              <a:rPr sz="1300">
+          </a:p>
+        </p:txBody>
+      </p:sp>
+      <p:pic>
+        <p:nvPicPr>
+          <p:cNvPr id="5" name="Picture 4" descr="wave1_tau.png"/>
+          <p:cNvPicPr>
+            <a:picLocks noChangeAspect="1"/>
+          </p:cNvPicPr>
+          <p:nvPr/>
+        </p:nvPicPr>
+        <p:blipFill>
+          <a:blip r:embed="rId2"/>
+          <a:stretch>
+            <a:fillRect/>
+          </a:stretch>
+        </p:blipFill>
+        <p:spPr>
+          <a:xfrm>
+            <a:off x="2486077" y="1828800"/>
+            <a:ext cx="7219540" cy="2926080"/>
+          </a:xfrm>
+          <a:prstGeom prst="rect">
+            <a:avLst/>
+          </a:prstGeom>
+        </p:spPr>
+      </p:pic>
+      <p:sp>
+        <p:nvSpPr>
+          <p:cNvPr id="6" name="TextBox 5"/>
+          <p:cNvSpPr txBox="1"/>
+          <p:nvPr/>
+        </p:nvSpPr>
+        <p:spPr>
+          <a:xfrm>
+            <a:off x="640080" y="5074920"/>
+            <a:ext cx="10881360" cy="1097280"/>
+          </a:xfrm>
+          <a:prstGeom prst="rect">
+            <a:avLst/>
+          </a:prstGeom>
+          <a:noFill/>
+        </p:spPr>
+        <p:txBody>
+          <a:bodyPr wrap="square" lIns="0" rIns="0" tIns="0" bIns="0">
+            <a:spAutoFit/>
+          </a:bodyPr>
+          <a:lstStyle/>
+          <a:p>
+            <a:pPr algn="l">
+              <a:lnSpc>
+                <a:spcPct val="115000"/>
+              </a:lnSpc>
+              <a:spcAft>
+                <a:spcPts val="600"/>
+              </a:spcAft>
+            </a:pPr>
+            <a:r>
+              <a:rPr sz="1700" b="0">
+                <a:solidFill>
+                  <a:srgbClr val="0B0B0B"/>
+                </a:solidFill>
+                <a:latin typeface="Calibri"/>
+              </a:rPr>
+              <a:t>Every arm beats its base metric at every length — no catastrophic forgetting.</a:t>
+            </a:r>
+          </a:p>
+          <a:p>
+            <a:pPr algn="l">
+              <a:lnSpc>
+                <a:spcPct val="115000"/>
+              </a:lnSpc>
+              <a:spcAft>
+                <a:spcPts val="600"/>
+              </a:spcAft>
+            </a:pPr>
+            <a:r>
+              <a:rPr sz="1700" b="0">
+                <a:solidFill>
+                  <a:srgbClr val="0B0B0B"/>
+                </a:solidFill>
+                <a:latin typeface="Calibri"/>
+              </a:rPr>
+              <a:t>Long-only training is best on documents; sentence-only on sentences.  The gap is small.</a:t>
+            </a:r>
+          </a:p>
+        </p:txBody>
+      </p:sp>
+    </p:spTree>
+  </p:cSld>
+  <p:clrMapOvr>
+    <a:masterClrMapping/>
+  </p:clrMapOvr>
+</p:sld>
+</file>
+
+<file path=ppt/slides/slide13.xml><?xml version="1.0" encoding="utf-8"?>
+<p:sld xmlns:a="http://schemas.openxmlformats.org/drawingml/2006/main" xmlns:p="http://schemas.openxmlformats.org/presentationml/2006/main" xmlns:r="http://schemas.openxmlformats.org/officeDocument/2006/relationships">
+  <p:cSld>
+    <p:bg>
+      <p:bgPr>
+        <a:solidFill>
+          <a:srgbClr val="FFFFFF"/>
+        </a:solidFill>
+        <a:effectLst/>
+      </p:bgPr>
+    </p:bg>
+    <p:spTree>
+      <p:nvGrpSpPr>
+        <p:cNvPr id="1" name=""/>
+        <p:cNvGrpSpPr/>
+        <p:nvPr/>
+      </p:nvGrpSpPr>
+      <p:grpSpPr/>
+      <p:sp>
+        <p:nvSpPr>
+          <p:cNvPr id="2" name="TextBox 1"/>
+          <p:cNvSpPr txBox="1"/>
+          <p:nvPr/>
+        </p:nvSpPr>
+        <p:spPr>
+          <a:xfrm>
+            <a:off x="640080" y="411480"/>
+            <a:ext cx="10972800" cy="822960"/>
+          </a:xfrm>
+          <a:prstGeom prst="rect">
+            <a:avLst/>
+          </a:prstGeom>
+          <a:noFill/>
+        </p:spPr>
+        <p:txBody>
+          <a:bodyPr wrap="square" lIns="0" rIns="0" tIns="0" bIns="0">
+            <a:spAutoFit/>
+          </a:bodyPr>
+          <a:lstStyle/>
+          <a:p>
+            <a:pPr algn="l">
+              <a:lnSpc>
+                <a:spcPct val="115000"/>
+              </a:lnSpc>
+              <a:spcAft>
+                <a:spcPts val="600"/>
+              </a:spcAft>
+            </a:pPr>
+            <a:r>
+              <a:rPr sz="3200" b="1">
+                <a:solidFill>
+                  <a:srgbClr val="0B0B0B"/>
+                </a:solidFill>
+                <a:latin typeface="Calibri"/>
+              </a:rPr>
+              <a:t>Discourse errors — no progress</a:t>
+            </a:r>
+          </a:p>
+        </p:txBody>
+      </p:sp>
+      <p:sp>
+        <p:nvSpPr>
+          <p:cNvPr id="3" name="TextBox 2"/>
+          <p:cNvSpPr txBox="1"/>
+          <p:nvPr/>
+        </p:nvSpPr>
+        <p:spPr>
+          <a:xfrm>
+            <a:off x="640080" y="1115568"/>
+            <a:ext cx="10972800" cy="457200"/>
+          </a:xfrm>
+          <a:prstGeom prst="rect">
+            <a:avLst/>
+          </a:prstGeom>
+          <a:noFill/>
+        </p:spPr>
+        <p:txBody>
+          <a:bodyPr wrap="square" lIns="0" rIns="0" tIns="0" bIns="0">
+            <a:spAutoFit/>
+          </a:bodyPr>
+          <a:lstStyle/>
+          <a:p>
+            <a:pPr algn="l">
+              <a:lnSpc>
+                <a:spcPct val="115000"/>
+              </a:lnSpc>
+              <a:spcAft>
+                <a:spcPts val="600"/>
+              </a:spcAft>
+            </a:pPr>
+            <a:r>
+              <a:rPr sz="1600" b="0">
                 <a:solidFill>
                   <a:srgbClr val="52514E"/>
                 </a:solidFill>
                 <a:latin typeface="Calibri"/>
               </a:rPr>
-              <a:t>runs finished</a:t>
-            </a:r>
-          </a:p>
-        </p:txBody>
-      </p:sp>
-      <p:sp>
-        <p:nvSpPr>
-          <p:cNvPr id="6" name="Rounded Rectangle 5"/>
+              <a:t>MetaDocEval: original vs perturbed document, accuracy per context window.</a:t>
+            </a:r>
+          </a:p>
+        </p:txBody>
+      </p:sp>
+      <p:sp>
+        <p:nvSpPr>
+          <p:cNvPr id="4" name="Rectangle 3"/>
           <p:cNvSpPr/>
           <p:nvPr/>
         </p:nvSpPr>
         <p:spPr>
           <a:xfrm>
-            <a:off x="3424428" y="2148840"/>
-            <a:ext cx="2528316" cy="1554480"/>
-          </a:xfrm>
-          <a:prstGeom prst="roundRect">
-            <a:avLst>
-              <a:gd name="adj" fmla="val 6000"/>
-            </a:avLst>
+            <a:off x="640080" y="1600200"/>
+            <a:ext cx="10881360" cy="25400"/>
+          </a:xfrm>
+          <a:prstGeom prst="rect">
+            <a:avLst/>
           </a:prstGeom>
           <a:solidFill>
-            <a:srgbClr val="F5F5F3"/>
+            <a:srgbClr val="E3E2DE"/>
           </a:solidFill>
           <a:ln>
             <a:noFill/>
@@ -3991,52 +4379,224 @@
           </a:fontRef>
         </p:style>
         <p:txBody>
-          <a:bodyPr rtlCol="0" anchor="ctr" wrap="square" lIns="109728" rIns="109728"/>
+          <a:bodyPr rtlCol="0" anchor="ctr"/>
           <a:lstStyle/>
           <a:p>
             <a:pPr algn="ctr"/>
-            <a:r>
-              <a:rPr sz="3000" b="1">
-                <a:solidFill>
-                  <a:srgbClr val="2A78D6"/>
-                </a:solidFill>
-                <a:latin typeface="Calibri"/>
-              </a:rPr>
-              <a:t>8</a:t>
-            </a:r>
-          </a:p>
-          <a:p>
-            <a:pPr algn="ctr"/>
-            <a:r>
-              <a:rPr sz="1300">
+          </a:p>
+        </p:txBody>
+      </p:sp>
+      <p:pic>
+        <p:nvPicPr>
+          <p:cNvPr id="5" name="Picture 4" descr="metadoceval_base.png"/>
+          <p:cNvPicPr>
+            <a:picLocks noChangeAspect="1"/>
+          </p:cNvPicPr>
+          <p:nvPr/>
+        </p:nvPicPr>
+        <p:blipFill>
+          <a:blip r:embed="rId2"/>
+          <a:stretch>
+            <a:fillRect/>
+          </a:stretch>
+        </p:blipFill>
+        <p:spPr>
+          <a:xfrm>
+            <a:off x="2804007" y="1828800"/>
+            <a:ext cx="6583680" cy="2926080"/>
+          </a:xfrm>
+          <a:prstGeom prst="rect">
+            <a:avLst/>
+          </a:prstGeom>
+        </p:spPr>
+      </p:pic>
+      <p:sp>
+        <p:nvSpPr>
+          <p:cNvPr id="6" name="TextBox 5"/>
+          <p:cNvSpPr txBox="1"/>
+          <p:nvPr/>
+        </p:nvSpPr>
+        <p:spPr>
+          <a:xfrm>
+            <a:off x="640080" y="5074920"/>
+            <a:ext cx="10881360" cy="1097280"/>
+          </a:xfrm>
+          <a:prstGeom prst="rect">
+            <a:avLst/>
+          </a:prstGeom>
+          <a:noFill/>
+        </p:spPr>
+        <p:txBody>
+          <a:bodyPr wrap="square" lIns="0" rIns="0" tIns="0" bIns="0">
+            <a:spAutoFit/>
+          </a:bodyPr>
+          <a:lstStyle/>
+          <a:p>
+            <a:pPr algn="l">
+              <a:lnSpc>
+                <a:spcPct val="115000"/>
+              </a:lnSpc>
+              <a:spcAft>
+                <a:spcPts val="600"/>
+              </a:spcAft>
+            </a:pPr>
+            <a:r>
+              <a:rPr sz="1700" b="0">
+                <a:solidFill>
+                  <a:srgbClr val="0B0B0B"/>
+                </a:solidFill>
+                <a:latin typeface="Calibri"/>
+              </a:rPr>
+              <a:t>No retrained arm improves with context — the gains above are score-level.</a:t>
+            </a:r>
+          </a:p>
+          <a:p>
+            <a:pPr algn="l">
+              <a:lnSpc>
+                <a:spcPct val="115000"/>
+              </a:lnSpc>
+              <a:spcAft>
+                <a:spcPts val="600"/>
+              </a:spcAft>
+            </a:pPr>
+            <a:r>
+              <a:rPr sz="1700" b="0">
+                <a:solidFill>
+                  <a:srgbClr val="0B0B0B"/>
+                </a:solidFill>
+                <a:latin typeface="Calibri"/>
+              </a:rPr>
+              <a:t>Training on longer text does not teach the metric to SEE document-level errors.</a:t>
+            </a:r>
+          </a:p>
+        </p:txBody>
+      </p:sp>
+    </p:spTree>
+  </p:cSld>
+  <p:clrMapOvr>
+    <a:masterClrMapping/>
+  </p:clrMapOvr>
+</p:sld>
+</file>
+
+<file path=ppt/slides/slide14.xml><?xml version="1.0" encoding="utf-8"?>
+<p:sld xmlns:a="http://schemas.openxmlformats.org/drawingml/2006/main" xmlns:p="http://schemas.openxmlformats.org/presentationml/2006/main" xmlns:r="http://schemas.openxmlformats.org/officeDocument/2006/relationships">
+  <p:cSld>
+    <p:bg>
+      <p:bgPr>
+        <a:solidFill>
+          <a:srgbClr val="FFFFFF"/>
+        </a:solidFill>
+        <a:effectLst/>
+      </p:bgPr>
+    </p:bg>
+    <p:spTree>
+      <p:nvGrpSpPr>
+        <p:cNvPr id="1" name=""/>
+        <p:cNvGrpSpPr/>
+        <p:nvPr/>
+      </p:nvGrpSpPr>
+      <p:grpSpPr/>
+      <p:sp>
+        <p:nvSpPr>
+          <p:cNvPr id="2" name="TextBox 1"/>
+          <p:cNvSpPr txBox="1"/>
+          <p:nvPr/>
+        </p:nvSpPr>
+        <p:spPr>
+          <a:xfrm>
+            <a:off x="640080" y="411480"/>
+            <a:ext cx="10972800" cy="822960"/>
+          </a:xfrm>
+          <a:prstGeom prst="rect">
+            <a:avLst/>
+          </a:prstGeom>
+          <a:noFill/>
+        </p:spPr>
+        <p:txBody>
+          <a:bodyPr wrap="square" lIns="0" rIns="0" tIns="0" bIns="0">
+            <a:spAutoFit/>
+          </a:bodyPr>
+          <a:lstStyle/>
+          <a:p>
+            <a:pPr algn="l">
+              <a:lnSpc>
+                <a:spcPct val="115000"/>
+              </a:lnSpc>
+              <a:spcAft>
+                <a:spcPts val="600"/>
+              </a:spcAft>
+            </a:pPr>
+            <a:r>
+              <a:rPr sz="3200" b="1">
+                <a:solidFill>
+                  <a:srgbClr val="0B0B0B"/>
+                </a:solidFill>
+                <a:latin typeface="Calibri"/>
+              </a:rPr>
+              <a:t>Audit finding — QE trained on truncated inputs</a:t>
+            </a:r>
+          </a:p>
+        </p:txBody>
+      </p:sp>
+      <p:sp>
+        <p:nvSpPr>
+          <p:cNvPr id="3" name="TextBox 2"/>
+          <p:cNvSpPr txBox="1"/>
+          <p:nvPr/>
+        </p:nvSpPr>
+        <p:spPr>
+          <a:xfrm>
+            <a:off x="640080" y="1115568"/>
+            <a:ext cx="10972800" cy="457200"/>
+          </a:xfrm>
+          <a:prstGeom prst="rect">
+            <a:avLst/>
+          </a:prstGeom>
+          <a:noFill/>
+        </p:spPr>
+        <p:txBody>
+          <a:bodyPr wrap="square" lIns="0" rIns="0" tIns="0" bIns="0">
+            <a:spAutoFit/>
+          </a:bodyPr>
+          <a:lstStyle/>
+          <a:p>
+            <a:pPr algn="l">
+              <a:lnSpc>
+                <a:spcPct val="115000"/>
+              </a:lnSpc>
+              <a:spcAft>
+                <a:spcPts val="600"/>
+              </a:spcAft>
+            </a:pPr>
+            <a:r>
+              <a:rPr sz="1600" b="0">
                 <a:solidFill>
                   <a:srgbClr val="52514E"/>
                 </a:solidFill>
                 <a:latin typeface="Calibri"/>
               </a:rPr>
-              <a:t>running now</a:t>
-            </a:r>
-          </a:p>
-        </p:txBody>
-      </p:sp>
-      <p:sp>
-        <p:nvSpPr>
-          <p:cNvPr id="7" name="Rounded Rectangle 6"/>
+              <a:t>CometKiwi concatenates mt + src into one 512-token sequence. Our filter capped each side.</a:t>
+            </a:r>
+          </a:p>
+        </p:txBody>
+      </p:sp>
+      <p:sp>
+        <p:nvSpPr>
+          <p:cNvPr id="4" name="Rectangle 3"/>
           <p:cNvSpPr/>
           <p:nvPr/>
         </p:nvSpPr>
         <p:spPr>
           <a:xfrm>
-            <a:off x="6208776" y="2148840"/>
-            <a:ext cx="2528316" cy="1554480"/>
-          </a:xfrm>
-          <a:prstGeom prst="roundRect">
-            <a:avLst>
-              <a:gd name="adj" fmla="val 6000"/>
-            </a:avLst>
+            <a:off x="640080" y="1600200"/>
+            <a:ext cx="10881360" cy="25400"/>
+          </a:xfrm>
+          <a:prstGeom prst="rect">
+            <a:avLst/>
           </a:prstGeom>
           <a:solidFill>
-            <a:srgbClr val="F5F5F3"/>
+            <a:srgbClr val="E3E2DE"/>
           </a:solidFill>
           <a:ln>
             <a:noFill/>
@@ -4058,44 +4618,23 @@
           </a:fontRef>
         </p:style>
         <p:txBody>
-          <a:bodyPr rtlCol="0" anchor="ctr" wrap="square" lIns="109728" rIns="109728"/>
+          <a:bodyPr rtlCol="0" anchor="ctr"/>
           <a:lstStyle/>
           <a:p>
             <a:pPr algn="ctr"/>
-            <a:r>
-              <a:rPr sz="3000" b="1">
-                <a:solidFill>
-                  <a:srgbClr val="2A78D6"/>
-                </a:solidFill>
-                <a:latin typeface="Calibri"/>
-              </a:rPr>
-              <a:t>26</a:t>
-            </a:r>
-          </a:p>
-          <a:p>
-            <a:pPr algn="ctr"/>
-            <a:r>
-              <a:rPr sz="1300">
-                <a:solidFill>
-                  <a:srgbClr val="52514E"/>
-                </a:solidFill>
-                <a:latin typeface="Calibri"/>
-              </a:rPr>
-              <a:t>queued</a:t>
-            </a:r>
-          </a:p>
-        </p:txBody>
-      </p:sp>
-      <p:sp>
-        <p:nvSpPr>
-          <p:cNvPr id="8" name="Rounded Rectangle 7"/>
+          </a:p>
+        </p:txBody>
+      </p:sp>
+      <p:sp>
+        <p:nvSpPr>
+          <p:cNvPr id="5" name="Rounded Rectangle 4"/>
           <p:cNvSpPr/>
           <p:nvPr/>
         </p:nvSpPr>
         <p:spPr>
           <a:xfrm>
-            <a:off x="8993124" y="2148840"/>
-            <a:ext cx="2528316" cy="1554480"/>
+            <a:off x="640080" y="2148840"/>
+            <a:ext cx="2528316" cy="1737360"/>
           </a:xfrm>
           <a:prstGeom prst="roundRect">
             <a:avLst>
@@ -4132,11 +4671,11 @@
             <a:r>
               <a:rPr sz="3000" b="1">
                 <a:solidFill>
-                  <a:srgbClr val="2A78D6"/>
-                </a:solidFill>
-                <a:latin typeface="Calibri"/>
-              </a:rPr>
-              <a:t>0</a:t>
+                  <a:srgbClr val="EB6834"/>
+                </a:solidFill>
+                <a:latin typeface="Calibri"/>
+              </a:rPr>
+              <a:t>7.8%</a:t>
             </a:r>
           </a:p>
           <a:p>
@@ -4148,7 +4687,212 @@
                 </a:solidFill>
                 <a:latin typeface="Calibri"/>
               </a:rPr>
-              <a:t>failures</a:t>
+              <a:t>native training rows
+overflowing</a:t>
+            </a:r>
+          </a:p>
+        </p:txBody>
+      </p:sp>
+      <p:sp>
+        <p:nvSpPr>
+          <p:cNvPr id="6" name="Rounded Rectangle 5"/>
+          <p:cNvSpPr/>
+          <p:nvPr/>
+        </p:nvSpPr>
+        <p:spPr>
+          <a:xfrm>
+            <a:off x="3424428" y="2148840"/>
+            <a:ext cx="2528316" cy="1737360"/>
+          </a:xfrm>
+          <a:prstGeom prst="roundRect">
+            <a:avLst>
+              <a:gd name="adj" fmla="val 6000"/>
+            </a:avLst>
+          </a:prstGeom>
+          <a:solidFill>
+            <a:srgbClr val="F5F5F3"/>
+          </a:solidFill>
+          <a:ln>
+            <a:noFill/>
+          </a:ln>
+          <a:effectLst/>
+        </p:spPr>
+        <p:style>
+          <a:lnRef idx="1">
+            <a:schemeClr val="accent1"/>
+          </a:lnRef>
+          <a:fillRef idx="3">
+            <a:schemeClr val="accent1"/>
+          </a:fillRef>
+          <a:effectRef idx="2">
+            <a:schemeClr val="accent1"/>
+          </a:effectRef>
+          <a:fontRef idx="minor">
+            <a:schemeClr val="lt1"/>
+          </a:fontRef>
+        </p:style>
+        <p:txBody>
+          <a:bodyPr rtlCol="0" anchor="ctr" wrap="square" lIns="109728" rIns="109728"/>
+          <a:lstStyle/>
+          <a:p>
+            <a:pPr algn="ctr"/>
+            <a:r>
+              <a:rPr sz="3000" b="1">
+                <a:solidFill>
+                  <a:srgbClr val="EB6834"/>
+                </a:solidFill>
+                <a:latin typeface="Calibri"/>
+              </a:rPr>
+              <a:t>10.7%</a:t>
+            </a:r>
+          </a:p>
+          <a:p>
+            <a:pPr algn="ctr"/>
+            <a:r>
+              <a:rPr sz="1300">
+                <a:solidFill>
+                  <a:srgbClr val="52514E"/>
+                </a:solidFill>
+                <a:latin typeface="Calibri"/>
+              </a:rPr>
+              <a:t>k=6 training rows
+overflowing</a:t>
+            </a:r>
+          </a:p>
+        </p:txBody>
+      </p:sp>
+      <p:sp>
+        <p:nvSpPr>
+          <p:cNvPr id="7" name="Rounded Rectangle 6"/>
+          <p:cNvSpPr/>
+          <p:nvPr/>
+        </p:nvSpPr>
+        <p:spPr>
+          <a:xfrm>
+            <a:off x="6208776" y="2148840"/>
+            <a:ext cx="2528316" cy="1737360"/>
+          </a:xfrm>
+          <a:prstGeom prst="roundRect">
+            <a:avLst>
+              <a:gd name="adj" fmla="val 6000"/>
+            </a:avLst>
+          </a:prstGeom>
+          <a:solidFill>
+            <a:srgbClr val="F5F5F3"/>
+          </a:solidFill>
+          <a:ln>
+            <a:noFill/>
+          </a:ln>
+          <a:effectLst/>
+        </p:spPr>
+        <p:style>
+          <a:lnRef idx="1">
+            <a:schemeClr val="accent1"/>
+          </a:lnRef>
+          <a:fillRef idx="3">
+            <a:schemeClr val="accent1"/>
+          </a:fillRef>
+          <a:effectRef idx="2">
+            <a:schemeClr val="accent1"/>
+          </a:effectRef>
+          <a:fontRef idx="minor">
+            <a:schemeClr val="lt1"/>
+          </a:fontRef>
+        </p:style>
+        <p:txBody>
+          <a:bodyPr rtlCol="0" anchor="ctr" wrap="square" lIns="109728" rIns="109728"/>
+          <a:lstStyle/>
+          <a:p>
+            <a:pPr algn="ctr"/>
+            <a:r>
+              <a:rPr sz="3000" b="1">
+                <a:solidFill>
+                  <a:srgbClr val="EB6834"/>
+                </a:solidFill>
+                <a:latin typeface="Calibri"/>
+              </a:rPr>
+              <a:t>~52%</a:t>
+            </a:r>
+          </a:p>
+          <a:p>
+            <a:pPr algn="ctr"/>
+            <a:r>
+              <a:rPr sz="1300">
+                <a:solidFill>
+                  <a:srgbClr val="52514E"/>
+                </a:solidFill>
+                <a:latin typeface="Calibri"/>
+              </a:rPr>
+              <a:t>of the source lost
+on overflowing eval docs</a:t>
+            </a:r>
+          </a:p>
+        </p:txBody>
+      </p:sp>
+      <p:sp>
+        <p:nvSpPr>
+          <p:cNvPr id="8" name="Rounded Rectangle 7"/>
+          <p:cNvSpPr/>
+          <p:nvPr/>
+        </p:nvSpPr>
+        <p:spPr>
+          <a:xfrm>
+            <a:off x="8993124" y="2148840"/>
+            <a:ext cx="2528316" cy="1737360"/>
+          </a:xfrm>
+          <a:prstGeom prst="roundRect">
+            <a:avLst>
+              <a:gd name="adj" fmla="val 6000"/>
+            </a:avLst>
+          </a:prstGeom>
+          <a:solidFill>
+            <a:srgbClr val="F5F5F3"/>
+          </a:solidFill>
+          <a:ln>
+            <a:noFill/>
+          </a:ln>
+          <a:effectLst/>
+        </p:spPr>
+        <p:style>
+          <a:lnRef idx="1">
+            <a:schemeClr val="accent1"/>
+          </a:lnRef>
+          <a:fillRef idx="3">
+            <a:schemeClr val="accent1"/>
+          </a:fillRef>
+          <a:effectRef idx="2">
+            <a:schemeClr val="accent1"/>
+          </a:effectRef>
+          <a:fontRef idx="minor">
+            <a:schemeClr val="lt1"/>
+          </a:fontRef>
+        </p:style>
+        <p:txBody>
+          <a:bodyPr rtlCol="0" anchor="ctr" wrap="square" lIns="109728" rIns="109728"/>
+          <a:lstStyle/>
+          <a:p>
+            <a:pPr algn="ctr"/>
+            <a:r>
+              <a:rPr sz="3000" b="1">
+                <a:solidFill>
+                  <a:srgbClr val="EB6834"/>
+                </a:solidFill>
+                <a:latin typeface="Calibri"/>
+              </a:rPr>
+              <a:t>0%</a:t>
+            </a:r>
+          </a:p>
+          <a:p>
+            <a:pPr algn="ctr"/>
+            <a:r>
+              <a:rPr sz="1300">
+                <a:solidFill>
+                  <a:srgbClr val="52514E"/>
+                </a:solidFill>
+                <a:latin typeface="Calibri"/>
+              </a:rPr>
+              <a:t>DA arms affected
+(sides encoded separately)</a:t>
             </a:r>
           </a:p>
         </p:txBody>
@@ -4161,8 +4905,8 @@
         </p:nvSpPr>
         <p:spPr>
           <a:xfrm>
-            <a:off x="640080" y="4023360"/>
-            <a:ext cx="10881360" cy="1005840"/>
+            <a:off x="640080" y="4343400"/>
+            <a:ext cx="10881360" cy="1463040"/>
           </a:xfrm>
           <a:prstGeom prst="rect">
             <a:avLst/>
@@ -4184,13 +4928,13 @@
               </a:spcAft>
             </a:pPr>
             <a:r>
-              <a:rPr sz="1800" b="0">
+              <a:rPr sz="1700" b="0">
                 <a:solidFill>
                   <a:srgbClr val="0B0B0B"/>
                 </a:solidFill>
                 <a:latin typeface="Calibri"/>
               </a:rPr>
-              <a:t>First signal, preliminary:  the long-only COMET-DA run improves its validation</a:t>
+              <a:t>Fix:  rows must now also satisfy  src + mt ≤ 508 tokens  — applied to the shared pools,</a:t>
             </a:r>
           </a:p>
           <a:p>
@@ -4203,38 +4947,15 @@
               </a:spcAft>
             </a:pPr>
             <a:r>
-              <a:rPr sz="1800" b="0">
+              <a:rPr sz="1700" b="0">
                 <a:solidFill>
                   <a:srgbClr val="0B0B0B"/>
                 </a:solidFill>
                 <a:latin typeface="Calibri"/>
               </a:rPr>
-              <a:t>correlation from 0.285 to 0.296.  Two runs out of 36 — not yet a result.</a:t>
-            </a:r>
-          </a:p>
-        </p:txBody>
-      </p:sp>
-      <p:sp>
-        <p:nvSpPr>
-          <p:cNvPr id="10" name="TextBox 9"/>
-          <p:cNvSpPr txBox="1"/>
-          <p:nvPr/>
-        </p:nvSpPr>
-        <p:spPr>
-          <a:xfrm>
-            <a:off x="640080" y="5212080"/>
-            <a:ext cx="10881360" cy="1005840"/>
-          </a:xfrm>
-          <a:prstGeom prst="rect">
-            <a:avLst/>
-          </a:prstGeom>
-          <a:noFill/>
-        </p:spPr>
-        <p:txBody>
-          <a:bodyPr wrap="square" lIns="0" rIns="0" tIns="0" bIns="0">
-            <a:spAutoFit/>
-          </a:bodyPr>
-          <a:lstStyle/>
+              <a:t>so DA and QE keep training on identical rows.  Redeploy:</a:t>
+            </a:r>
+          </a:p>
           <a:p>
             <a:pPr algn="l">
               <a:lnSpc>
@@ -4245,32 +4966,224 @@
               </a:spcAft>
             </a:pPr>
             <a:r>
-              <a:rPr sz="1600" b="0">
-                <a:solidFill>
-                  <a:srgbClr val="52514E"/>
-                </a:solidFill>
-                <a:latin typeface="Calibri"/>
-              </a:rPr>
-              <a:t>Next:  full length-profile table per mixture, restoration point, frozen vs trained,</a:t>
-            </a:r>
-          </a:p>
+              <a:rPr sz="1700" b="0">
+                <a:solidFill>
+                  <a:srgbClr val="0B0B0B"/>
+                </a:solidFill>
+                <a:latin typeface="Calibri"/>
+              </a:rPr>
+              <a:t>RUN=1 SUBMIT=1  experiments/length_training/slurm/deploy_concat_fix.sh</a:t>
+            </a:r>
+          </a:p>
+        </p:txBody>
+      </p:sp>
+    </p:spTree>
+  </p:cSld>
+  <p:clrMapOvr>
+    <a:masterClrMapping/>
+  </p:clrMapOvr>
+</p:sld>
+</file>
+
+<file path=ppt/slides/slide15.xml><?xml version="1.0" encoding="utf-8"?>
+<p:sld xmlns:a="http://schemas.openxmlformats.org/drawingml/2006/main" xmlns:p="http://schemas.openxmlformats.org/presentationml/2006/main" xmlns:r="http://schemas.openxmlformats.org/officeDocument/2006/relationships">
+  <p:cSld>
+    <p:bg>
+      <p:bgPr>
+        <a:solidFill>
+          <a:srgbClr val="FFFFFF"/>
+        </a:solidFill>
+        <a:effectLst/>
+      </p:bgPr>
+    </p:bg>
+    <p:spTree>
+      <p:nvGrpSpPr>
+        <p:cNvPr id="1" name=""/>
+        <p:cNvGrpSpPr/>
+        <p:nvPr/>
+      </p:nvGrpSpPr>
+      <p:grpSpPr/>
+      <p:sp>
+        <p:nvSpPr>
+          <p:cNvPr id="2" name="TextBox 1"/>
+          <p:cNvSpPr txBox="1"/>
+          <p:nvPr/>
+        </p:nvSpPr>
+        <p:spPr>
+          <a:xfrm>
+            <a:off x="640080" y="411480"/>
+            <a:ext cx="10972800" cy="822960"/>
+          </a:xfrm>
+          <a:prstGeom prst="rect">
+            <a:avLst/>
+          </a:prstGeom>
+          <a:noFill/>
+        </p:spPr>
+        <p:txBody>
+          <a:bodyPr wrap="square" lIns="0" rIns="0" tIns="0" bIns="0">
+            <a:spAutoFit/>
+          </a:bodyPr>
+          <a:lstStyle/>
           <a:p>
             <a:pPr algn="l">
               <a:lnSpc>
                 <a:spcPct val="115000"/>
               </a:lnSpc>
               <a:spcAft>
-                <a:spcPts val="800"/>
+                <a:spcPts val="600"/>
               </a:spcAft>
             </a:pPr>
             <a:r>
-              <a:rPr sz="1600" b="0">
-                <a:solidFill>
-                  <a:srgbClr val="52514E"/>
-                </a:solidFill>
-                <a:latin typeface="Calibri"/>
-              </a:rPr>
-              <a:t>DA vs QE, real documents vs aggregated sentences, then MetaDocEval accuracy.</a:t>
+              <a:rPr sz="3200" b="1">
+                <a:solidFill>
+                  <a:srgbClr val="0B0B0B"/>
+                </a:solidFill>
+                <a:latin typeface="Calibri"/>
+              </a:rPr>
+              <a:t>Next</a:t>
+            </a:r>
+          </a:p>
+        </p:txBody>
+      </p:sp>
+      <p:sp>
+        <p:nvSpPr>
+          <p:cNvPr id="3" name="Rectangle 2"/>
+          <p:cNvSpPr/>
+          <p:nvPr/>
+        </p:nvSpPr>
+        <p:spPr>
+          <a:xfrm>
+            <a:off x="640080" y="1600200"/>
+            <a:ext cx="10881360" cy="25400"/>
+          </a:xfrm>
+          <a:prstGeom prst="rect">
+            <a:avLst/>
+          </a:prstGeom>
+          <a:solidFill>
+            <a:srgbClr val="E3E2DE"/>
+          </a:solidFill>
+          <a:ln>
+            <a:noFill/>
+          </a:ln>
+          <a:effectLst/>
+        </p:spPr>
+        <p:style>
+          <a:lnRef idx="1">
+            <a:schemeClr val="accent1"/>
+          </a:lnRef>
+          <a:fillRef idx="3">
+            <a:schemeClr val="accent1"/>
+          </a:fillRef>
+          <a:effectRef idx="2">
+            <a:schemeClr val="accent1"/>
+          </a:effectRef>
+          <a:fontRef idx="minor">
+            <a:schemeClr val="lt1"/>
+          </a:fontRef>
+        </p:style>
+        <p:txBody>
+          <a:bodyPr rtlCol="0" anchor="ctr"/>
+          <a:lstStyle/>
+          <a:p>
+            <a:pPr algn="ctr"/>
+          </a:p>
+        </p:txBody>
+      </p:sp>
+      <p:sp>
+        <p:nvSpPr>
+          <p:cNvPr id="4" name="TextBox 3"/>
+          <p:cNvSpPr txBox="1"/>
+          <p:nvPr/>
+        </p:nvSpPr>
+        <p:spPr>
+          <a:xfrm>
+            <a:off x="640080" y="2103120"/>
+            <a:ext cx="10881360" cy="2194560"/>
+          </a:xfrm>
+          <a:prstGeom prst="rect">
+            <a:avLst/>
+          </a:prstGeom>
+          <a:noFill/>
+        </p:spPr>
+        <p:txBody>
+          <a:bodyPr wrap="square" lIns="0" rIns="0" tIns="0" bIns="0">
+            <a:spAutoFit/>
+          </a:bodyPr>
+          <a:lstStyle/>
+          <a:p>
+            <a:pPr algn="l">
+              <a:lnSpc>
+                <a:spcPct val="115000"/>
+              </a:lnSpc>
+              <a:spcAft>
+                <a:spcPts val="1000"/>
+              </a:spcAft>
+            </a:pPr>
+            <a:r>
+              <a:rPr sz="2000" b="0">
+                <a:solidFill>
+                  <a:srgbClr val="0B0B0B"/>
+                </a:solidFill>
+                <a:latin typeface="Calibri"/>
+              </a:rPr>
+              <a:t>1.  Re-run the first wave on the fixed pools (v2) — QE arms without truncation.</a:t>
+            </a:r>
+          </a:p>
+          <a:p>
+            <a:pPr algn="l">
+              <a:lnSpc>
+                <a:spcPct val="115000"/>
+              </a:lnSpc>
+              <a:spcAft>
+                <a:spcPts val="1000"/>
+              </a:spcAft>
+            </a:pPr>
+            <a:r>
+              <a:rPr sz="2000" b="0">
+                <a:solidFill>
+                  <a:srgbClr val="0B0B0B"/>
+                </a:solidFill>
+                <a:latin typeface="Calibri"/>
+              </a:rPr>
+              <a:t>2.  The remaining 28 arms: map the restoration point between f=0 and f=100.</a:t>
+            </a:r>
+          </a:p>
+          <a:p>
+            <a:pPr algn="l">
+              <a:lnSpc>
+                <a:spcPct val="115000"/>
+              </a:lnSpc>
+              <a:spcAft>
+                <a:spcPts val="1000"/>
+              </a:spcAft>
+            </a:pPr>
+            <a:r>
+              <a:rPr sz="2000" b="0">
+                <a:solidFill>
+                  <a:srgbClr val="0B0B0B"/>
+                </a:solidFill>
+                <a:latin typeface="Calibri"/>
+              </a:rPr>
+              <a:t>3.  Discourse competence needs more than data composition — longer training,</a:t>
+            </a:r>
+          </a:p>
+          <a:p>
+            <a:pPr algn="l">
+              <a:lnSpc>
+                <a:spcPct val="115000"/>
+              </a:lnSpc>
+              <a:spcAft>
+                <a:spcPts val="1000"/>
+              </a:spcAft>
+            </a:pPr>
+            <a:r>
+              <a:rPr sz="2000" b="0">
+                <a:solidFill>
+                  <a:srgbClr val="0B0B0B"/>
+                </a:solidFill>
+                <a:latin typeface="Calibri"/>
+              </a:rPr>
+              <a:t>     document-level supervision, or architectural change.</a:t>
             </a:r>
           </a:p>
         </p:txBody>
@@ -4446,7 +5359,7 @@
         <p:spPr>
           <a:xfrm>
             <a:off x="1295247" y="2148840"/>
-            <a:ext cx="9601200" cy="2245895"/>
+            <a:ext cx="9601200" cy="2243509"/>
           </a:xfrm>
           <a:prstGeom prst="rect">
             <a:avLst/>
@@ -5728,8 +6641,8 @@
         </p:blipFill>
         <p:spPr>
           <a:xfrm>
-            <a:off x="1886252" y="1920240"/>
-            <a:ext cx="8419191" cy="3566160"/>
+            <a:off x="1964911" y="1920240"/>
+            <a:ext cx="8261873" cy="3566160"/>
           </a:xfrm>
           <a:prstGeom prst="rect">
             <a:avLst/>
@@ -6206,8 +7119,8 @@
         </p:blipFill>
         <p:spPr>
           <a:xfrm>
-            <a:off x="626257" y="1920240"/>
-            <a:ext cx="10939180" cy="3017520"/>
+            <a:off x="631617" y="1920240"/>
+            <a:ext cx="10928461" cy="3017520"/>
           </a:xfrm>
           <a:prstGeom prst="rect">
             <a:avLst/>
@@ -6464,8 +7377,8 @@
         </p:blipFill>
         <p:spPr>
           <a:xfrm>
-            <a:off x="2008637" y="1874519"/>
-            <a:ext cx="8174421" cy="3108960"/>
+            <a:off x="2086694" y="1874519"/>
+            <a:ext cx="8018306" cy="3108960"/>
           </a:xfrm>
           <a:prstGeom prst="rect">
             <a:avLst/>

</xml_diff>